<commit_message>
Redesign login throttle: bounded store, address-wide limit, Retry-After, TRUSTED_PROXIES
Co-Authored-By: Claude Sonnet 5.5 <noreply@anthropic.com>
Claude-Session: https://claude.ai/code/session_01VtiD3sYzdwe2Z45NHChjBt
</commit_message>
<xml_diff>
--- a/docs/Review_3_Presentation.pptx
+++ b/docs/Review_3_Presentation.pptx
@@ -582,7 +582,7 @@
           <a:lstStyle/>
           <a:p>
             <a:r>
-              <a:t>Be upfront about the deferred throttle redesign and that HTTPS was not exercised.</a:t>
+              <a:t>The throttle redesign is covered by offline tests only; HTTPS was not exercised.</a:t>
             </a:r>
           </a:p>
         </p:txBody>
@@ -4978,7 +4978,7 @@
                 </a:solidFill>
                 <a:latin typeface="Calibri"/>
               </a:rPr>
-              <a:t>Login throttle is in-process: memory grows, not proxy-aware, resets on restart</a:t>
+              <a:t>Login throttle is bounded and proxy-aware, but per process: resets on restart, not shared by workers</a:t>
             </a:r>
           </a:p>
           <a:p>
@@ -5649,7 +5649,7 @@
                 </a:solidFill>
                 <a:latin typeface="Calibri"/>
               </a:rPr>
-              <a:t>159 tests PASSED (140 offline + 19 live on Oracle 21c XE); 16 queries ran live</a:t>
+              <a:t>174 tests PASSED (155 offline + 19 live on Oracle 21c XE); 16 queries ran live</a:t>
             </a:r>
           </a:p>
         </p:txBody>
@@ -5885,7 +5885,7 @@
                 </a:solidFill>
                 <a:latin typeface="Calibri"/>
               </a:rPr>
-              <a:t>Throttle redesign, HTTPS deployment, recorded role walkthrough</a:t>
+              <a:t>HTTPS deployment, recorded role walkthrough, shared throttle store if several workers</a:t>
             </a:r>
           </a:p>
         </p:txBody>
@@ -10668,7 +10668,7 @@
                 </a:solidFill>
                 <a:latin typeface="Calibri"/>
               </a:rPr>
-              <a:t>159</a:t>
+              <a:t>174</a:t>
             </a:r>
           </a:p>
         </p:txBody>
@@ -10967,7 +10967,7 @@
                 <a:gridCol w="5120640"/>
                 <a:gridCol w="2880360"/>
               </a:tblGrid>
-              <a:tr h="381000">
+              <a:tr h="326571">
                 <a:tc>
                   <a:txBody>
                     <a:bodyPr/>
@@ -11035,7 +11035,7 @@
                   </a:tcPr>
                 </a:tc>
               </a:tr>
-              <a:tr h="381000">
+              <a:tr h="326571">
                 <a:tc>
                   <a:txBody>
                     <a:bodyPr/>
@@ -11103,7 +11103,7 @@
                   </a:tcPr>
                 </a:tc>
               </a:tr>
-              <a:tr h="381000">
+              <a:tr h="326571">
                 <a:tc>
                   <a:txBody>
                     <a:bodyPr/>
@@ -11171,7 +11171,7 @@
                   </a:tcPr>
                 </a:tc>
               </a:tr>
-              <a:tr h="381000">
+              <a:tr h="326571">
                 <a:tc>
                   <a:txBody>
                     <a:bodyPr/>
@@ -11239,7 +11239,7 @@
                   </a:tcPr>
                 </a:tc>
               </a:tr>
-              <a:tr h="381000">
+              <a:tr h="326571">
                 <a:tc>
                   <a:txBody>
                     <a:bodyPr/>
@@ -11274,7 +11274,7 @@
                           </a:solidFill>
                           <a:latin typeface="Calibri"/>
                         </a:rPr>
-                        <a:t>Sign-in, roles, throttle, redirects, hashing</a:t>
+                        <a:t>Sign-in, roles, redirects, hashing</a:t>
                       </a:r>
                     </a:p>
                   </a:txBody>
@@ -11296,7 +11296,7 @@
                           </a:solidFill>
                           <a:latin typeface="Calibri"/>
                         </a:rPr>
-                        <a:t>64 PASSED</a:t>
+                        <a:t>65 PASSED</a:t>
                       </a:r>
                     </a:p>
                   </a:txBody>
@@ -11307,7 +11307,7 @@
                   </a:tcPr>
                 </a:tc>
               </a:tr>
-              <a:tr h="381000">
+              <a:tr h="326571">
                 <a:tc>
                   <a:txBody>
                     <a:bodyPr/>
@@ -11320,7 +11320,7 @@
                           </a:solidFill>
                           <a:latin typeface="Calibri"/>
                         </a:rPr>
-                        <a:t>test_oracle_integration.py</a:t>
+                        <a:t>test_throttle.py</a:t>
                       </a:r>
                     </a:p>
                   </a:txBody>
@@ -11342,7 +11342,7 @@
                           </a:solidFill>
                           <a:latin typeface="Calibri"/>
                         </a:rPr>
-                        <a:t>Live Oracle (student run, 2026-10-22)</a:t>
+                        <a:t>Login throttle, proxy header handling</a:t>
                       </a:r>
                     </a:p>
                   </a:txBody>
@@ -11364,13 +11364,81 @@
                           </a:solidFill>
                           <a:latin typeface="Calibri"/>
                         </a:rPr>
+                        <a:t>14 PASSED</a:t>
+                      </a:r>
+                    </a:p>
+                  </a:txBody>
+                  <a:tcPr>
+                    <a:solidFill>
+                      <a:srgbClr val="141B33"/>
+                    </a:solidFill>
+                  </a:tcPr>
+                </a:tc>
+              </a:tr>
+              <a:tr h="326574">
+                <a:tc>
+                  <a:txBody>
+                    <a:bodyPr/>
+                    <a:lstStyle/>
+                    <a:p>
+                      <a:r>
+                        <a:rPr sz="1300" b="0">
+                          <a:solidFill>
+                            <a:srgbClr val="E8EEF8"/>
+                          </a:solidFill>
+                          <a:latin typeface="Calibri"/>
+                        </a:rPr>
+                        <a:t>test_oracle_integration.py</a:t>
+                      </a:r>
+                    </a:p>
+                  </a:txBody>
+                  <a:tcPr>
+                    <a:solidFill>
+                      <a:srgbClr val="1C2547"/>
+                    </a:solidFill>
+                  </a:tcPr>
+                </a:tc>
+                <a:tc>
+                  <a:txBody>
+                    <a:bodyPr/>
+                    <a:lstStyle/>
+                    <a:p>
+                      <a:r>
+                        <a:rPr sz="1300" b="0">
+                          <a:solidFill>
+                            <a:srgbClr val="E8EEF8"/>
+                          </a:solidFill>
+                          <a:latin typeface="Calibri"/>
+                        </a:rPr>
+                        <a:t>Live Oracle (student run, 2026-10-22)</a:t>
+                      </a:r>
+                    </a:p>
+                  </a:txBody>
+                  <a:tcPr>
+                    <a:solidFill>
+                      <a:srgbClr val="1C2547"/>
+                    </a:solidFill>
+                  </a:tcPr>
+                </a:tc>
+                <a:tc>
+                  <a:txBody>
+                    <a:bodyPr/>
+                    <a:lstStyle/>
+                    <a:p>
+                      <a:r>
+                        <a:rPr sz="1300" b="0">
+                          <a:solidFill>
+                            <a:srgbClr val="E8EEF8"/>
+                          </a:solidFill>
+                          <a:latin typeface="Calibri"/>
+                        </a:rPr>
                         <a:t>19 PASSED</a:t>
                       </a:r>
                     </a:p>
                   </a:txBody>
                   <a:tcPr>
                     <a:solidFill>
-                      <a:srgbClr val="141B33"/>
+                      <a:srgbClr val="1C2547"/>
                     </a:solidFill>
                   </a:tcPr>
                 </a:tc>

</xml_diff>